<commit_message>
Sync JATM R1 Devin Review fixes: reference order, response letter fallbacks, PPTX/STROBE title, and verify citation check
Co-Authored-By: Tatsuki Onishi <bougtoir@gmail.com>
</commit_message>
<xml_diff>
--- a/vaporizer-price-study/papers/jatm_figures.pptx
+++ b/vaporizer-price-study/papers/jatm_figures.pptx
@@ -3124,11 +3124,7 @@
               </a:defRPr>
             </a:pPr>
             <a:r>
-              <a:t>Targeted Environmental Regulation Without Observable Collateral Market Damage:</a:t>
-            </a:r>
-            <a:br/>
-            <a:r>
-              <a:t>The EU Desflurane Ban and Secondary Market Vaporizer Prices</a:t>
+              <a:t>Association between the EU desflurane phase-out and secondary market vaporizer prices: an observational time-series analysis</a:t>
             </a:r>
           </a:p>
           <a:p>

</xml_diff>